<commit_message>
instruments: terminology GX-MS → GC-MS (glossary), quiz regenerated
Co-Authored-By: Claude Fable 5.1 <noreply@anthropic.com>
Claude-Session: https://claude.ai/code/session_01SNYTV6SjoFqojTd3hPRMtP
</commit_message>
<xml_diff>
--- a/out/instr-03-gcms-asoslar.pptx
+++ b/out/instr-03-gcms-asoslar.pptx
@@ -1832,7 +1832,7 @@
           </a:p>
           <a:p>
             <a:r>
-              <a:t>- Morfin miqdori GX-MS yoki YuSSX-MS bilan aniqlanadi; kitobda sezgirlik «10-11» deb yozilgan.</a:t>
+              <a:t>- Morfin miqdori GC-MS yoki YuSSX-MS bilan aniqlanadi; kitobda sezgirlik «10-11» deb yozilgan.</a:t>
             </a:r>
           </a:p>
         </p:txBody>
@@ -2530,7 +2530,7 @@
           </a:p>
           <a:p>
             <a:r>
-              <a:t>- GX-MS asbobining xavfsizlik va tuning qoidalari bu deckda berilmagan — ishlab chiqaruvchi qo‘llanmasi talab etiladi.</a:t>
+              <a:t>- GC-MS asbobining xavfsizlik va tuning qoidalari bu deckda berilmagan — ishlab chiqaruvchi qo‘llanmasi talab etiladi.</a:t>
             </a:r>
           </a:p>
         </p:txBody>
@@ -2600,7 +2600,7 @@
           <a:lstStyle/>
           <a:p>
             <a:r>
-              <a:t>Egasidan: qaysi GX-MS modeli (Shimadzu GCMS-QP?) va ish kompyuteri ekran suratlari kerak.</a:t>
+              <a:t>Egasidan: qaysi GC-MS modeli (Shimadzu GCMS-QP?) va ish kompyuteri ekran suratlari kerak.</a:t>
             </a:r>
           </a:p>
           <a:p/>
@@ -2611,7 +2611,7 @@
           </a:p>
           <a:p>
             <a:r>
-              <a:t>- Shimadzu GX-MS menyu va sozlamalari (tuning, harorat, ionlar) bu deckda berilmadi.</a:t>
+              <a:t>- Shimadzu GC-MS menyu va sozlamalari (tuning, harorat, ionlar) bu deckda berilmadi.</a:t>
             </a:r>
           </a:p>
           <a:p>
@@ -6438,7 +6438,7 @@
                 </a:solidFill>
                 <a:latin typeface="Georgia"/>
               </a:rPr>
-              <a:t>GX-MS da ishlash usullari: asoslar</a:t>
+              <a:t>GC-MS da ishlash usullari: asoslar</a:t>
             </a:r>
           </a:p>
         </p:txBody>
@@ -6690,7 +6690,7 @@
                 </a:solidFill>
                 <a:latin typeface="Calibri"/>
               </a:rPr>
-              <a:t>GX-MS da ishlash usullari: asoslar</a:t>
+              <a:t>GC-MS da ishlash usullari: asoslar</a:t>
             </a:r>
           </a:p>
         </p:txBody>
@@ -6764,7 +6764,7 @@
                 </a:solidFill>
                 <a:latin typeface="Calibri"/>
               </a:rPr>
-              <a:t>▸  EI — GX-MS da eng ko‘p ishlatiladigan ionlanish rejimi; deyarli barcha asboblarda standart.</a:t>
+              <a:t>▸  EI — GC-MS da eng ko‘p ishlatiladigan ionlanish rejimi; deyarli barcha asboblarda standart.</a:t>
             </a:r>
           </a:p>
           <a:p>
@@ -7550,7 +7550,7 @@
                 </a:solidFill>
                 <a:latin typeface="Calibri"/>
               </a:rPr>
-              <a:t>GX-MS da ishlash usullari: asoslar</a:t>
+              <a:t>GC-MS da ishlash usullari: asoslar</a:t>
             </a:r>
           </a:p>
         </p:txBody>
@@ -8582,7 +8582,7 @@
                 </a:solidFill>
                 <a:latin typeface="Calibri"/>
               </a:rPr>
-              <a:t>GX-MS da ishlash usullari: asoslar</a:t>
+              <a:t>GC-MS da ishlash usullari: asoslar</a:t>
             </a:r>
           </a:p>
         </p:txBody>
@@ -9324,7 +9324,7 @@
                 </a:solidFill>
                 <a:latin typeface="Calibri"/>
               </a:rPr>
-              <a:t>GX-MS da ishlash usullari: asoslar</a:t>
+              <a:t>GC-MS da ishlash usullari: asoslar</a:t>
             </a:r>
           </a:p>
         </p:txBody>
@@ -10191,7 +10191,7 @@
                 </a:solidFill>
                 <a:latin typeface="Calibri"/>
               </a:rPr>
-              <a:t>GX-MS da ishlash usullari: asoslar</a:t>
+              <a:t>GC-MS da ishlash usullari: asoslar</a:t>
             </a:r>
           </a:p>
         </p:txBody>
@@ -11033,7 +11033,7 @@
                 </a:solidFill>
                 <a:latin typeface="Calibri"/>
               </a:rPr>
-              <a:t>GX-MS da ishlash usullari: asoslar</a:t>
+              <a:t>GC-MS da ishlash usullari: asoslar</a:t>
             </a:r>
           </a:p>
         </p:txBody>
@@ -11123,7 +11123,7 @@
                 </a:solidFill>
                 <a:latin typeface="Calibri"/>
               </a:rPr>
-              <a:t>▸  Boshqa barcha ishlarni kvadrupolli GX-MS bajara oladi.</a:t>
+              <a:t>▸  Boshqa barcha ishlarni kvadrupolli GC-MS bajara oladi.</a:t>
             </a:r>
           </a:p>
           <a:p>
@@ -11750,7 +11750,7 @@
                 </a:solidFill>
                 <a:latin typeface="Calibri"/>
               </a:rPr>
-              <a:t>GX-MS da ishlash usullari: asoslar</a:t>
+              <a:t>GC-MS da ishlash usullari: asoslar</a:t>
             </a:r>
           </a:p>
         </p:txBody>
@@ -12492,7 +12492,7 @@
                 </a:solidFill>
                 <a:latin typeface="Calibri"/>
               </a:rPr>
-              <a:t>GX-MS da ishlash usullari: asoslar</a:t>
+              <a:t>GC-MS da ishlash usullari: asoslar</a:t>
             </a:r>
           </a:p>
         </p:txBody>
@@ -13684,7 +13684,7 @@
                 </a:solidFill>
                 <a:latin typeface="Calibri"/>
               </a:rPr>
-              <a:t>GX-MS da ishlash usullari: asoslar</a:t>
+              <a:t>GC-MS da ishlash usullari: asoslar</a:t>
             </a:r>
           </a:p>
         </p:txBody>
@@ -15019,7 +15019,7 @@
                 </a:solidFill>
                 <a:latin typeface="Calibri"/>
               </a:rPr>
-              <a:t>GX-MS da ishlash usullari: asoslar</a:t>
+              <a:t>GC-MS da ishlash usullari: asoslar</a:t>
             </a:r>
           </a:p>
         </p:txBody>
@@ -15777,7 +15777,7 @@
                 </a:solidFill>
                 <a:latin typeface="Calibri"/>
               </a:rPr>
-              <a:t>GX-MS da ishlash usullari: asoslar</a:t>
+              <a:t>GC-MS da ishlash usullari: asoslar</a:t>
             </a:r>
           </a:p>
         </p:txBody>
@@ -15851,7 +15851,7 @@
                 </a:solidFill>
                 <a:latin typeface="Calibri"/>
               </a:rPr>
-              <a:t>▸  Xromatografik usullar: YuQX, GSX, GelX, YuSSX, GX-MS, YuSSX-MS.</a:t>
+              <a:t>▸  Xromatografik usullar: YuQX, GSX, GelX, YuSSX, GC-MS, YuSSX-MS.</a:t>
             </a:r>
           </a:p>
           <a:p>
@@ -15867,7 +15867,7 @@
                 </a:solidFill>
                 <a:latin typeface="Calibri"/>
               </a:rPr>
-              <a:t>▸  GX-MS — gaz-xromato-mass-spektrometriya; YuSSX-MS — yuqori samarali suyuqlik xromatografiya-mass spektrometriya.</a:t>
+              <a:t>▸  GC-MS — gaz-xromato-mass-spektrometriya; YuSSX-MS — yuqori samarali suyuqlik xromatografiya-mass spektrometriya.</a:t>
             </a:r>
           </a:p>
           <a:p>
@@ -16877,7 +16877,7 @@
                 </a:solidFill>
                 <a:latin typeface="Calibri"/>
               </a:rPr>
-              <a:t>GX-MS ishlash tartibi (umumlashtirilgan)</a:t>
+              <a:t>GC-MS ishlash tartibi (umumlashtirilgan)</a:t>
             </a:r>
           </a:p>
         </p:txBody>
@@ -17129,7 +17129,7 @@
                 </a:solidFill>
                 <a:latin typeface="Calibri"/>
               </a:rPr>
-              <a:t>GX-MS da ishlash usullari: asoslar</a:t>
+              <a:t>GC-MS da ishlash usullari: asoslar</a:t>
             </a:r>
           </a:p>
         </p:txBody>
@@ -17203,7 +17203,7 @@
                 </a:solidFill>
                 <a:latin typeface="Calibri"/>
               </a:rPr>
-              <a:t>▸  GX-MS ning yakuniy natijasi — mass-xromatogramma.</a:t>
+              <a:t>▸  GC-MS ning yakuniy natijasi — mass-xromatogramma.</a:t>
             </a:r>
           </a:p>
           <a:p>
@@ -17767,7 +17767,7 @@
                 </a:solidFill>
                 <a:latin typeface="Calibri"/>
               </a:rPr>
-              <a:t>GX-MS da ishlash usullari: asoslar</a:t>
+              <a:t>GC-MS da ishlash usullari: asoslar</a:t>
             </a:r>
           </a:p>
         </p:txBody>
@@ -18595,7 +18595,7 @@
                 </a:solidFill>
                 <a:latin typeface="Calibri"/>
               </a:rPr>
-              <a:t>GX-MS da ishlash usullari: asoslar</a:t>
+              <a:t>GC-MS da ishlash usullari: asoslar</a:t>
             </a:r>
           </a:p>
         </p:txBody>
@@ -19803,7 +19803,7 @@
                 </a:solidFill>
                 <a:latin typeface="Calibri"/>
               </a:rPr>
-              <a:t>GX-MS da ishlash usullari: asoslar</a:t>
+              <a:t>GC-MS da ishlash usullari: asoslar</a:t>
             </a:r>
           </a:p>
         </p:txBody>
@@ -20441,7 +20441,7 @@
                 </a:solidFill>
                 <a:latin typeface="Calibri"/>
               </a:rPr>
-              <a:t>GX-MS da ishlash usullari: asoslar</a:t>
+              <a:t>GC-MS da ishlash usullari: asoslar</a:t>
             </a:r>
           </a:p>
         </p:txBody>
@@ -21315,7 +21315,7 @@
                 </a:solidFill>
                 <a:latin typeface="Calibri"/>
               </a:rPr>
-              <a:t>GX-MS da ishlash usullari: asoslar</a:t>
+              <a:t>GC-MS da ishlash usullari: asoslar</a:t>
             </a:r>
           </a:p>
         </p:txBody>
@@ -22007,7 +22007,7 @@
                 </a:solidFill>
                 <a:latin typeface="Calibri"/>
               </a:rPr>
-              <a:t>GX-MS da ishlash usullari: asoslar</a:t>
+              <a:t>GC-MS da ishlash usullari: asoslar</a:t>
             </a:r>
           </a:p>
         </p:txBody>
@@ -22721,7 +22721,7 @@
                 </a:solidFill>
                 <a:latin typeface="Calibri"/>
               </a:rPr>
-              <a:t>GX-MS da ishlash usullari: asoslar</a:t>
+              <a:t>GC-MS da ishlash usullari: asoslar</a:t>
             </a:r>
           </a:p>
         </p:txBody>
@@ -22795,7 +22795,7 @@
                 </a:solidFill>
                 <a:latin typeface="Calibri"/>
               </a:rPr>
-              <a:t>▸  LSD GX-MS da 44, 72, 207, 221, 280, 323 m/z xarakterli spektrlar hosil qiladi.</a:t>
+              <a:t>▸  LSD GC-MS da 44, 72, 207, 221, 280, 323 m/z xarakterli spektrlar hosil qiladi.</a:t>
             </a:r>
           </a:p>
           <a:p>
@@ -23385,7 +23385,7 @@
                 </a:solidFill>
                 <a:latin typeface="Georgia"/>
               </a:rPr>
-              <a:t>GX-MS qo‘llanadigan ob’ektlar</a:t>
+              <a:t>GC-MS qo‘llanadigan ob’ektlar</a:t>
             </a:r>
           </a:p>
         </p:txBody>
@@ -23419,7 +23419,7 @@
                 </a:solidFill>
                 <a:latin typeface="Calibri"/>
               </a:rPr>
-              <a:t>GX-MS da ishlash usullari: asoslar</a:t>
+              <a:t>GC-MS da ishlash usullari: asoslar</a:t>
             </a:r>
           </a:p>
         </p:txBody>
@@ -23493,7 +23493,7 @@
                 </a:solidFill>
                 <a:latin typeface="Calibri"/>
               </a:rPr>
-              <a:t>▸  Morfin miqdori GX-MS yoki YuSSX-MS bilan aniqlanadi; kitobda sezgirlik «10-11» deb yozilgan.</a:t>
+              <a:t>▸  Morfin miqdori GC-MS yoki YuSSX-MS bilan aniqlanadi; kitobda sezgirlik «10-11» deb yozilgan.</a:t>
             </a:r>
           </a:p>
           <a:p>
@@ -23509,7 +23509,7 @@
                 </a:solidFill>
                 <a:latin typeface="Calibri"/>
               </a:rPr>
-              <a:t>▸  Kodein va narkotin ham GX-MS yoki YuSSX-MS usullarida aniqlanadi.</a:t>
+              <a:t>▸  Kodein va narkotin ham GC-MS yoki YuSSX-MS usullarida aniqlanadi.</a:t>
             </a:r>
           </a:p>
           <a:p>
@@ -23525,7 +23525,7 @@
                 </a:solidFill>
                 <a:latin typeface="Calibri"/>
               </a:rPr>
-              <a:t>▸  Geksaxloran izomerlari va sintetik piretroidlar GSX, YuSSX yoki GX-MS bilan aniqlanadi.</a:t>
+              <a:t>▸  Geksaxloran izomerlari va sintetik piretroidlar GSX, YuSSX yoki GC-MS bilan aniqlanadi.</a:t>
             </a:r>
           </a:p>
         </p:txBody>
@@ -23582,7 +23582,7 @@
                 </a:solidFill>
                 <a:latin typeface="Calibri"/>
               </a:rPr>
-              <a:t>GX-MS qo‘llanishi (kitob)</a:t>
+              <a:t>GC-MS qo‘llanishi (kitob)</a:t>
             </a:r>
           </a:p>
         </p:txBody>
@@ -24440,7 +24440,7 @@
                 </a:solidFill>
                 <a:latin typeface="Georgia"/>
               </a:rPr>
-              <a:t>GX-MS qo‘llanish misollari: usullar jadvali</a:t>
+              <a:t>GC-MS qo‘llanish misollari: usullar jadvali</a:t>
             </a:r>
           </a:p>
         </p:txBody>
@@ -24474,7 +24474,7 @@
                 </a:solidFill>
                 <a:latin typeface="Calibri"/>
               </a:rPr>
-              <a:t>GX-MS da ishlash usullari: asoslar</a:t>
+              <a:t>GC-MS da ishlash usullari: asoslar</a:t>
             </a:r>
           </a:p>
         </p:txBody>
@@ -24564,7 +24564,7 @@
                 </a:solidFill>
                 <a:latin typeface="Calibri"/>
               </a:rPr>
-              <a:t>▸  Geroin yoki uning metabolitlari 6-monoasetilmorfin va morfin GX-MS va YuSSX-MS usullarida aniqlanadi.</a:t>
+              <a:t>▸  Geroin yoki uning metabolitlari 6-monoasetilmorfin va morfin GC-MS va YuSSX-MS usullarida aniqlanadi.</a:t>
             </a:r>
           </a:p>
           <a:p>
@@ -24596,7 +24596,7 @@
                 </a:solidFill>
                 <a:latin typeface="Calibri"/>
               </a:rPr>
-              <a:t>▸  Geksaxloran izomerlari va metabolitlari GSX, GX-MS va YuSSX usullarida aniqlanadi.</a:t>
+              <a:t>▸  Geksaxloran izomerlari va metabolitlari GSX, GC-MS va YuSSX usullarida aniqlanadi.</a:t>
             </a:r>
           </a:p>
         </p:txBody>
@@ -24700,7 +24700,7 @@
                             <a:srgbClr val="1F2937"/>
                           </a:solidFill>
                         </a:rPr>
-                        <a:t>GSX, GX-MS, immunobiologik</a:t>
+                        <a:t>GSX, GC-MS, immunobiologik</a:t>
                       </a:r>
                     </a:p>
                   </a:txBody>
@@ -24744,7 +24744,7 @@
                             <a:srgbClr val="1F2937"/>
                           </a:solidFill>
                         </a:rPr>
-                        <a:t>GX-MS, YuSSX-MS</a:t>
+                        <a:t>GC-MS, YuSSX-MS</a:t>
                       </a:r>
                     </a:p>
                   </a:txBody>
@@ -24788,7 +24788,7 @@
                             <a:srgbClr val="1F2937"/>
                           </a:solidFill>
                         </a:rPr>
-                        <a:t>GX-MS yoki YuSSX-MS</a:t>
+                        <a:t>GC-MS yoki YuSSX-MS</a:t>
                       </a:r>
                     </a:p>
                   </a:txBody>
@@ -24832,7 +24832,7 @@
                             <a:srgbClr val="1F2937"/>
                           </a:solidFill>
                         </a:rPr>
-                        <a:t>UB-spektrofotometriya, GX-MS</a:t>
+                        <a:t>UB-spektrofotometriya, GC-MS</a:t>
                       </a:r>
                     </a:p>
                   </a:txBody>
@@ -24876,7 +24876,7 @@
                             <a:srgbClr val="1F2937"/>
                           </a:solidFill>
                         </a:rPr>
-                        <a:t>GSX, GX-MS, YuSSX</a:t>
+                        <a:t>GSX, GC-MS, YuSSX</a:t>
                       </a:r>
                     </a:p>
                   </a:txBody>
@@ -24920,7 +24920,7 @@
                 </a:solidFill>
                 <a:latin typeface="Calibri"/>
               </a:rPr>
-              <a:t>GX-MS qo‘llanishi (gmt 29–38, 100; toks 159)</a:t>
+              <a:t>GC-MS qo‘llanishi (gmt 29–38, 100; toks 159)</a:t>
             </a:r>
           </a:p>
         </p:txBody>
@@ -25138,7 +25138,7 @@
                 </a:solidFill>
                 <a:latin typeface="Georgia"/>
               </a:rPr>
-              <a:t>GX-MS nima</a:t>
+              <a:t>GC-MS nima</a:t>
             </a:r>
           </a:p>
         </p:txBody>
@@ -25172,7 +25172,7 @@
                 </a:solidFill>
                 <a:latin typeface="Calibri"/>
               </a:rPr>
-              <a:t>GX-MS da ishlash usullari: asoslar</a:t>
+              <a:t>GC-MS da ishlash usullari: asoslar</a:t>
             </a:r>
           </a:p>
         </p:txBody>
@@ -25246,7 +25246,7 @@
                 </a:solidFill>
                 <a:latin typeface="Calibri"/>
               </a:rPr>
-              <a:t>▸  GX-MS — gaz-xromato-mass-spektrometriya.</a:t>
+              <a:t>▸  GC-MS — gaz-xromato-mass-spektrometriya.</a:t>
             </a:r>
           </a:p>
           <a:p>
@@ -25510,7 +25510,7 @@
                 </a:solidFill>
                 <a:latin typeface="Calibri"/>
               </a:rPr>
-              <a:t>GX-MS</a:t>
+              <a:t>GC-MS</a:t>
             </a:r>
           </a:p>
         </p:txBody>
@@ -25914,7 +25914,7 @@
                 </a:solidFill>
                 <a:latin typeface="Calibri"/>
               </a:rPr>
-              <a:t>GX-MS da ishlash usullari: asoslar</a:t>
+              <a:t>GC-MS da ishlash usullari: asoslar</a:t>
             </a:r>
           </a:p>
         </p:txBody>
@@ -27266,7 +27266,7 @@
                 </a:solidFill>
                 <a:latin typeface="Calibri"/>
               </a:rPr>
-              <a:t>GX-MS da ishlash usullari: asoslar</a:t>
+              <a:t>GC-MS da ishlash usullari: asoslar</a:t>
             </a:r>
           </a:p>
         </p:txBody>
@@ -27958,7 +27958,7 @@
                 </a:solidFill>
                 <a:latin typeface="Calibri"/>
               </a:rPr>
-              <a:t>GX-MS da ishlash usullari: asoslar</a:t>
+              <a:t>GC-MS da ishlash usullari: asoslar</a:t>
             </a:r>
           </a:p>
         </p:txBody>
@@ -28786,7 +28786,7 @@
                 </a:solidFill>
                 <a:latin typeface="Calibri"/>
               </a:rPr>
-              <a:t>GX-MS da ishlash usullari: asoslar</a:t>
+              <a:t>GC-MS da ishlash usullari: asoslar</a:t>
             </a:r>
           </a:p>
         </p:txBody>
@@ -30114,7 +30114,7 @@
                 </a:solidFill>
                 <a:latin typeface="Calibri"/>
               </a:rPr>
-              <a:t>GX-MS da ishlash usullari: asoslar</a:t>
+              <a:t>GC-MS da ishlash usullari: asoslar</a:t>
             </a:r>
           </a:p>
         </p:txBody>
@@ -30752,7 +30752,7 @@
                 </a:solidFill>
                 <a:latin typeface="Calibri"/>
               </a:rPr>
-              <a:t>GX-MS da ishlash usullari: asoslar</a:t>
+              <a:t>GC-MS da ishlash usullari: asoslar</a:t>
             </a:r>
           </a:p>
         </p:txBody>
@@ -31562,7 +31562,7 @@
                 </a:solidFill>
                 <a:latin typeface="Georgia"/>
               </a:rPr>
-              <a:t>GX-MS cheklovlari</a:t>
+              <a:t>GC-MS cheklovlari</a:t>
             </a:r>
           </a:p>
         </p:txBody>
@@ -31596,7 +31596,7 @@
                 </a:solidFill>
                 <a:latin typeface="Calibri"/>
               </a:rPr>
-              <a:t>GX-MS da ishlash usullari: asoslar</a:t>
+              <a:t>GC-MS da ishlash usullari: asoslar</a:t>
             </a:r>
           </a:p>
         </p:txBody>
@@ -32288,7 +32288,7 @@
                 </a:solidFill>
                 <a:latin typeface="Calibri"/>
               </a:rPr>
-              <a:t>GX-MS da ishlash usullari: asoslar</a:t>
+              <a:t>GC-MS da ishlash usullari: asoslar</a:t>
             </a:r>
           </a:p>
         </p:txBody>
@@ -32410,7 +32410,7 @@
                 </a:solidFill>
                 <a:latin typeface="Calibri"/>
               </a:rPr>
-              <a:t>▸  GX-MS asbobining xavfsizlik va tuning qoidalari bu deckda berilmagan — ishlab chiqaruvchi qo‘llanmasi talab etiladi.</a:t>
+              <a:t>▸  GC-MS asbobining xavfsizlik va tuning qoidalari bu deckda berilmagan — ishlab chiqaruvchi qo‘llanmasi talab etiladi.</a:t>
             </a:r>
           </a:p>
         </p:txBody>
@@ -33113,7 +33113,7 @@
                 </a:solidFill>
                 <a:latin typeface="Calibri"/>
               </a:rPr>
-              <a:t>GX-MS da ishlash usullari: asoslar</a:t>
+              <a:t>GC-MS da ishlash usullari: asoslar</a:t>
             </a:r>
           </a:p>
         </p:txBody>
@@ -33187,7 +33187,7 @@
                 </a:solidFill>
                 <a:latin typeface="Calibri"/>
               </a:rPr>
-              <a:t>▸  Shimadzu GX-MS menyu va sozlamalari (tuning, harorat, ionlar) bu deckda berilmadi.</a:t>
+              <a:t>▸  Shimadzu GC-MS menyu va sozlamalari (tuning, harorat, ionlar) bu deckda berilmadi.</a:t>
             </a:r>
           </a:p>
           <a:p>
@@ -33471,7 +33471,7 @@
                 </a:solidFill>
                 <a:latin typeface="Calibri"/>
               </a:rPr>
-              <a:t>GX-MS da ishlash usullari: asoslar</a:t>
+              <a:t>GC-MS da ishlash usullari: asoslar</a:t>
             </a:r>
           </a:p>
         </p:txBody>
@@ -33561,7 +33561,7 @@
                 </a:solidFill>
                 <a:latin typeface="Calibri"/>
               </a:rPr>
-              <a:t>▸  Peshobdan olingan ajratma GX-MS usulida tahlil qilinganda kokaetilen topilgan.</a:t>
+              <a:t>▸  Peshobdan olingan ajratma GC-MS usulida tahlil qilinganda kokaetilen topilgan.</a:t>
             </a:r>
           </a:p>
           <a:p>
@@ -33821,7 +33821,7 @@
                   <a:srgbClr val="FFFFFF"/>
                 </a:solidFill>
               </a:rPr>
-              <a:t>GX-MS tahlili</a:t>
+              <a:t>GC-MS tahlili</a:t>
             </a:r>
           </a:p>
         </p:txBody>
@@ -34265,7 +34265,7 @@
                 </a:solidFill>
                 <a:latin typeface="Georgia"/>
               </a:rPr>
-              <a:t>GX-MS blok-sxemasi</a:t>
+              <a:t>GC-MS blok-sxemasi</a:t>
             </a:r>
           </a:p>
         </p:txBody>
@@ -34299,7 +34299,7 @@
                 </a:solidFill>
                 <a:latin typeface="Calibri"/>
               </a:rPr>
-              <a:t>GX-MS da ishlash usullari: asoslar</a:t>
+              <a:t>GC-MS da ishlash usullari: asoslar</a:t>
             </a:r>
           </a:p>
         </p:txBody>
@@ -34971,7 +34971,7 @@
                 </a:solidFill>
                 <a:latin typeface="Calibri"/>
               </a:rPr>
-              <a:t>GX-MS yo‘li</a:t>
+              <a:t>GC-MS yo‘li</a:t>
             </a:r>
           </a:p>
         </p:txBody>
@@ -35223,7 +35223,7 @@
                 </a:solidFill>
                 <a:latin typeface="Calibri"/>
               </a:rPr>
-              <a:t>GX-MS da ishlash usullari: asoslar</a:t>
+              <a:t>GC-MS da ishlash usullari: asoslar</a:t>
             </a:r>
           </a:p>
         </p:txBody>
@@ -35297,7 +35297,7 @@
                 </a:solidFill>
                 <a:latin typeface="Calibri"/>
               </a:rPr>
-              <a:t>▸  GX-MS: GX ajratadi, MS ionlaydi (EI, 70 eV), m/z bo‘yicha ajratadi va ion intensivligini o‘lchaydi.</a:t>
+              <a:t>▸  GC-MS: GX ajratadi, MS ionlaydi (EI, 70 eV), m/z bo‘yicha ajratadi va ion intensivligini o‘lchaydi.</a:t>
             </a:r>
           </a:p>
           <a:p>
@@ -36575,7 +36575,7 @@
                 </a:solidFill>
                 <a:latin typeface="Calibri"/>
               </a:rPr>
-              <a:t>GX-MS da ishlash usullari: asoslar</a:t>
+              <a:t>GC-MS da ishlash usullari: asoslar</a:t>
             </a:r>
           </a:p>
         </p:txBody>
@@ -36965,7 +36965,7 @@
                 </a:solidFill>
                 <a:latin typeface="Calibri"/>
               </a:rPr>
-              <a:t>GX-MS da ishlash usullari: asoslar</a:t>
+              <a:t>GC-MS da ishlash usullari: asoslar</a:t>
             </a:r>
           </a:p>
         </p:txBody>
@@ -37323,7 +37323,7 @@
                 </a:solidFill>
                 <a:latin typeface="Calibri"/>
               </a:rPr>
-              <a:t>GX-MS da ishlash usullari: asoslar</a:t>
+              <a:t>GC-MS da ishlash usullari: asoslar</a:t>
             </a:r>
           </a:p>
         </p:txBody>
@@ -37663,7 +37663,7 @@
                 </a:solidFill>
                 <a:latin typeface="Calibri"/>
               </a:rPr>
-              <a:t>GX-MS da ishlash usullari: asoslar</a:t>
+              <a:t>GC-MS da ishlash usullari: asoslar</a:t>
             </a:r>
           </a:p>
         </p:txBody>
@@ -38491,7 +38491,7 @@
                 </a:solidFill>
                 <a:latin typeface="Calibri"/>
               </a:rPr>
-              <a:t>GX-MS da ishlash usullari: asoslar</a:t>
+              <a:t>GC-MS da ishlash usullari: asoslar</a:t>
             </a:r>
           </a:p>
         </p:txBody>
@@ -39668,7 +39668,7 @@
                 </a:solidFill>
                 <a:latin typeface="Calibri"/>
               </a:rPr>
-              <a:t>GX-MS da ishlash usullari: asoslar</a:t>
+              <a:t>GC-MS da ishlash usullari: asoslar</a:t>
             </a:r>
           </a:p>
         </p:txBody>
@@ -40700,7 +40700,7 @@
                 </a:solidFill>
                 <a:latin typeface="Calibri"/>
               </a:rPr>
-              <a:t>GX-MS da ishlash usullari: asoslar</a:t>
+              <a:t>GC-MS da ishlash usullari: asoslar</a:t>
             </a:r>
           </a:p>
         </p:txBody>
@@ -41417,7 +41417,7 @@
                 </a:solidFill>
                 <a:latin typeface="Calibri"/>
               </a:rPr>
-              <a:t>GX-MS da ishlash usullari: asoslar</a:t>
+              <a:t>GC-MS da ishlash usullari: asoslar</a:t>
             </a:r>
           </a:p>
         </p:txBody>

</xml_diff>